<commit_message>
All India: reasons for removal state by state; overall report and deck; plain Election Commission sections
A new India analysis with a state table of the draft-roll removals and their
reasons for 31 states and union territories, a source and flags for every
row, and a method page. The header switch is now All India / Bihar /
Hyderabad. An overall report (PDF and page) and deck cover India, Bihar and
Hyderabad. Every 'what an audit needs' section is now a short section on what
the Election Commission should do, and the audit framing is gone from the
pages, reports and decks. Blank pages after the cover and contents removed
from all three PDFs.

Co-Authored-By: Claude Opus 5.5 <noreply@anthropic.com>
Claude-Session: https://claude.ai/code/session_01FWx24PCx3Jw4SUDQC6oU7o
</commit_message>
<xml_diff>
--- a/reports/hyderabad-old-city-sir-2026-deck.pptx
+++ b/reports/hyderabad-old-city-sir-2026-deck.pptx
@@ -126,7 +126,7 @@
 </p:presentation>
 </file>
 
-<file path=ppt/charts/chart13.xml><?xml version="1.0" encoding="utf-8"?>
+<file path=ppt/charts/chart19.xml><?xml version="1.0" encoding="utf-8"?>
 <c:chartSpace xmlns:c="http://schemas.openxmlformats.org/drawingml/2006/chart" xmlns:a="http://schemas.openxmlformats.org/drawingml/2006/main" xmlns:r="http://schemas.openxmlformats.org/officeDocument/2006/relationships">
   <c:date1904 val="0"/>
   <c:roundedCorners val="1"/>
@@ -590,7 +590,7 @@
 </c:chartSpace>
 </file>
 
-<file path=ppt/charts/chart14.xml><?xml version="1.0" encoding="utf-8"?>
+<file path=ppt/charts/chart20.xml><?xml version="1.0" encoding="utf-8"?>
 <c:chartSpace xmlns:c="http://schemas.openxmlformats.org/drawingml/2006/chart" xmlns:a="http://schemas.openxmlformats.org/drawingml/2006/main" xmlns:r="http://schemas.openxmlformats.org/officeDocument/2006/relationships">
   <c:date1904 val="0"/>
   <c:roundedCorners val="1"/>
@@ -1144,7 +1144,7 @@
 </c:chartSpace>
 </file>
 
-<file path=ppt/charts/chart15.xml><?xml version="1.0" encoding="utf-8"?>
+<file path=ppt/charts/chart21.xml><?xml version="1.0" encoding="utf-8"?>
 <c:chartSpace xmlns:c="http://schemas.openxmlformats.org/drawingml/2006/chart" xmlns:a="http://schemas.openxmlformats.org/drawingml/2006/main" xmlns:r="http://schemas.openxmlformats.org/officeDocument/2006/relationships">
   <c:date1904 val="0"/>
   <c:roundedCorners val="1"/>
@@ -1414,7 +1414,7 @@
 </c:chartSpace>
 </file>
 
-<file path=ppt/charts/chart16.xml><?xml version="1.0" encoding="utf-8"?>
+<file path=ppt/charts/chart22.xml><?xml version="1.0" encoding="utf-8"?>
 <c:chartSpace xmlns:c="http://schemas.openxmlformats.org/drawingml/2006/chart" xmlns:a="http://schemas.openxmlformats.org/drawingml/2006/main" xmlns:r="http://schemas.openxmlformats.org/officeDocument/2006/relationships">
   <c:date1904 val="0"/>
   <c:roundedCorners val="1"/>
@@ -1766,7 +1766,7 @@
 </c:chartSpace>
 </file>
 
-<file path=ppt/charts/chart17.xml><?xml version="1.0" encoding="utf-8"?>
+<file path=ppt/charts/chart23.xml><?xml version="1.0" encoding="utf-8"?>
 <c:chartSpace xmlns:c="http://schemas.openxmlformats.org/drawingml/2006/chart" xmlns:a="http://schemas.openxmlformats.org/drawingml/2006/main" xmlns:r="http://schemas.openxmlformats.org/officeDocument/2006/relationships">
   <c:date1904 val="0"/>
   <c:roundedCorners val="1"/>
@@ -2130,7 +2130,7 @@
 </c:chartSpace>
 </file>
 
-<file path=ppt/charts/chart18.xml><?xml version="1.0" encoding="utf-8"?>
+<file path=ppt/charts/chart24.xml><?xml version="1.0" encoding="utf-8"?>
 <c:chartSpace xmlns:c="http://schemas.openxmlformats.org/drawingml/2006/chart" xmlns:a="http://schemas.openxmlformats.org/drawingml/2006/main" xmlns:r="http://schemas.openxmlformats.org/officeDocument/2006/relationships">
   <c:date1904 val="0"/>
   <c:roundedCorners val="1"/>
@@ -2494,7 +2494,7 @@
 </c:chartSpace>
 </file>
 
-<file path=ppt/charts/chart19.xml><?xml version="1.0" encoding="utf-8"?>
+<file path=ppt/charts/chart25.xml><?xml version="1.0" encoding="utf-8"?>
 <c:chartSpace xmlns:c="http://schemas.openxmlformats.org/drawingml/2006/chart" xmlns:a="http://schemas.openxmlformats.org/drawingml/2006/main" xmlns:r="http://schemas.openxmlformats.org/officeDocument/2006/relationships">
   <c:date1904 val="0"/>
   <c:roundedCorners val="1"/>
@@ -2835,7 +2835,7 @@
 </c:chartSpace>
 </file>
 
-<file path=ppt/charts/chart20.xml><?xml version="1.0" encoding="utf-8"?>
+<file path=ppt/charts/chart26.xml><?xml version="1.0" encoding="utf-8"?>
 <c:chartSpace xmlns:c="http://schemas.openxmlformats.org/drawingml/2006/chart" xmlns:a="http://schemas.openxmlformats.org/drawingml/2006/main" xmlns:r="http://schemas.openxmlformats.org/officeDocument/2006/relationships">
   <c:date1904 val="0"/>
   <c:roundedCorners val="1"/>
@@ -3099,7 +3099,7 @@
 </c:chartSpace>
 </file>
 
-<file path=ppt/charts/chart21.xml><?xml version="1.0" encoding="utf-8"?>
+<file path=ppt/charts/chart27.xml><?xml version="1.0" encoding="utf-8"?>
 <c:chartSpace xmlns:c="http://schemas.openxmlformats.org/drawingml/2006/chart" xmlns:a="http://schemas.openxmlformats.org/drawingml/2006/main" xmlns:r="http://schemas.openxmlformats.org/officeDocument/2006/relationships">
   <c:date1904 val="0"/>
   <c:roundedCorners val="1"/>
@@ -3463,7 +3463,7 @@
 </c:chartSpace>
 </file>
 
-<file path=ppt/charts/chart22.xml><?xml version="1.0" encoding="utf-8"?>
+<file path=ppt/charts/chart28.xml><?xml version="1.0" encoding="utf-8"?>
 <c:chartSpace xmlns:c="http://schemas.openxmlformats.org/drawingml/2006/chart" xmlns:a="http://schemas.openxmlformats.org/drawingml/2006/main" xmlns:r="http://schemas.openxmlformats.org/officeDocument/2006/relationships">
   <c:date1904 val="0"/>
   <c:roundedCorners val="1"/>
@@ -10128,50 +10128,6 @@
           </a:graphicData>
         </a:graphic>
       </p:graphicFrame>
-      <p:sp>
-        <p:nvSpPr>
-          <p:cNvPr id="49" name="Text 45"/>
-          <p:cNvSpPr txBox="1"/>
-          <p:nvPr/>
-        </p:nvSpPr>
-        <p:spPr>
-          <a:xfrm>
-            <a:off x="6675120" y="3749040"/>
-            <a:ext cx="4967935" cy="1097280"/>
-          </a:xfrm>
-          <a:prstGeom prst="rect">
-            <a:avLst/>
-          </a:prstGeom>
-          <a:noFill/>
-          <a:ln/>
-        </p:spPr>
-        <p:txBody>
-          <a:bodyPr wrap="square" lIns="0" tIns="0" rIns="0" bIns="0" rtlCol="0" anchor="t">
-            <a:normAutofit/>
-          </a:bodyPr>
-          <a:lstStyle/>
-          <a:p>
-            <a:pPr indent="0" marL="0">
-              <a:spcAft>
-                <a:spcPts val="800"/>
-              </a:spcAft>
-              <a:buNone/>
-            </a:pPr>
-            <a:r>
-              <a:rPr lang="en-US" sz="1400" dirty="0">
-                <a:solidFill>
-                  <a:srgbClr val="4D5B69"/>
-                </a:solidFill>
-                <a:latin typeface="Calibri" pitchFamily="34" charset="0"/>
-                <a:ea typeface="Calibri" pitchFamily="34" charset="-122"/>
-                <a:cs typeface="Calibri" pitchFamily="34" charset="-120"/>
-              </a:rPr>
-              <a:t>A part far above the rest of its constituency is where checking on the ground should start.</a:t>
-            </a:r>
-            <a:endParaRPr lang="en-US" sz="1400" dirty="0"/>
-          </a:p>
-        </p:txBody>
-      </p:sp>
     </p:spTree>
   </p:cSld>
   <p:clrMapOvr>
@@ -25190,7 +25146,7 @@
                 <a:ea typeface="Calibri" pitchFamily="34" charset="-122"/>
                 <a:cs typeface="Calibri" pitchFamily="34" charset="-120"/>
               </a:rPr>
-              <a:t>LIMITS AND NEXT STEPS</a:t>
+              <a:t>LIMITS</a:t>
             </a:r>
             <a:endParaRPr lang="en-US" sz="1100" dirty="0"/>
           </a:p>
@@ -26343,7 +26299,7 @@
                 <a:ea typeface="Calibri" pitchFamily="34" charset="-122"/>
                 <a:cs typeface="Calibri" pitchFamily="34" charset="-120"/>
               </a:rPr>
-              <a:t>LIMITS AND NEXT STEPS</a:t>
+              <a:t>WHAT THE ELECTION COMMISSION SHOULD DO</a:t>
             </a:r>
             <a:endParaRPr lang="en-US" sz="1100" dirty="0"/>
           </a:p>
@@ -26384,7 +26340,7 @@
                 <a:ea typeface="Cambria" pitchFamily="34" charset="-122"/>
                 <a:cs typeface="Cambria" pitchFamily="34" charset="-120"/>
               </a:rPr>
-              <a:t>What checking needs before the final roll</a:t>
+              <a:t>Before the final roll</a:t>
             </a:r>
             <a:endParaRPr lang="en-US" sz="2700" dirty="0"/>
           </a:p>
@@ -27308,7 +27264,7 @@
                 <a:ea typeface="Calibri" pitchFamily="34" charset="-122"/>
                 <a:cs typeface="Calibri" pitchFamily="34" charset="-120"/>
               </a:rPr>
-              <a:t>Verify every removal entered as "untraceable or absent", 1,37,825 names, by a visit with notice and a record of the attempt.</a:t>
+              <a:t>Record and publish the basis for every removal entered as "untraceable or absent", 1,37,825 names: the visits made and the notice given.</a:t>
             </a:r>
             <a:endParaRPr lang="en-US" sz="1700" dirty="0"/>
           </a:p>
@@ -27330,7 +27286,7 @@
                 <a:ea typeface="Calibri" pitchFamily="34" charset="-122"/>
                 <a:cs typeface="Calibri" pitchFamily="34" charset="-120"/>
               </a:rPr>
-              <a:t>Review every removal of an elector with no link to the 2002 roll.</a:t>
+              <a:t>Publish how removals of electors with no link to the 2002 roll were decided.</a:t>
             </a:r>
             <a:endParaRPr lang="en-US" sz="1700" dirty="0"/>
           </a:p>
@@ -27352,7 +27308,7 @@
                 <a:ea typeface="Calibri" pitchFamily="34" charset="-122"/>
                 <a:cs typeface="Calibri" pitchFamily="34" charset="-120"/>
               </a:rPr>
-              <a:t>Hearing schedules that give each elector time to be heard, instead of slots listing hundreds of cases.</a:t>
+              <a:t>Schedule hearings so that each case can be heard, rather than listing hundreds of cases in one slot.</a:t>
             </a:r>
             <a:endParaRPr lang="en-US" sz="1700" dirty="0"/>
           </a:p>
@@ -27374,7 +27330,7 @@
                 <a:ea typeface="Calibri" pitchFamily="34" charset="-122"/>
                 <a:cs typeface="Calibri" pitchFamily="34" charset="-120"/>
               </a:rPr>
-              <a:t>Ground checks in the 30 parts that lost more than 60% of their roll, and in parts far above their constituency's median.</a:t>
+              <a:t>Explain the removals in the 30 parts that lost more than 60% of their roll.</a:t>
             </a:r>
             <a:endParaRPr lang="en-US" sz="1700" dirty="0"/>
           </a:p>
@@ -29536,7 +29492,27 @@
                 <a:ea typeface="Calibri" pitchFamily="34" charset="-122"/>
                 <a:cs typeface="Calibri" pitchFamily="34" charset="-120"/>
               </a:rPr>
-              <a:t>Limits and next steps   17–18</a:t>
+              <a:t>Limits   17–17</a:t>
+            </a:r>
+            <a:endParaRPr lang="en-US" sz="1700" dirty="0"/>
+          </a:p>
+          <a:p>
+            <a:pPr indent="0" marL="0">
+              <a:spcAft>
+                <a:spcPts val="1200"/>
+              </a:spcAft>
+              <a:buNone/>
+            </a:pPr>
+            <a:r>
+              <a:rPr lang="en-US" sz="1700" dirty="0">
+                <a:solidFill>
+                  <a:srgbClr val="1C2833"/>
+                </a:solidFill>
+                <a:latin typeface="Calibri" pitchFamily="34" charset="0"/>
+                <a:ea typeface="Calibri" pitchFamily="34" charset="-122"/>
+                <a:cs typeface="Calibri" pitchFamily="34" charset="-120"/>
+              </a:rPr>
+              <a:t>What the Election Commission should do   18–18</a:t>
             </a:r>
             <a:endParaRPr lang="en-US" sz="1700" dirty="0"/>
           </a:p>
@@ -36952,7 +36928,7 @@
                 <a:ea typeface="Calibri" pitchFamily="34" charset="-122"/>
                 <a:cs typeface="Calibri" pitchFamily="34" charset="-120"/>
               </a:rPr>
-              <a:t>Each reason is an officer's entry, not a finding. Untraceable entries rest on someone not being found, and are where checking should start.</a:t>
+              <a:t>Each reason is an officer's entry, not a finding. An untraceable entry records only that someone was not found.</a:t>
             </a:r>
             <a:endParaRPr lang="en-US" sz="1350" dirty="0"/>
           </a:p>

</xml_diff>

<commit_message>
Decks: a one-slide section reads as its slide number in the contents
Co-Authored-By: Claude Opus 5.5 <noreply@anthropic.com>
Claude-Session: https://claude.ai/code/session_01FWx24PCx3Jw4SUDQC6oU7o
</commit_message>
<xml_diff>
--- a/reports/hyderabad-old-city-sir-2026-deck.pptx
+++ b/reports/hyderabad-old-city-sir-2026-deck.pptx
@@ -127,7 +127,7 @@
 </p:presentation>
 </file>
 
-<file path=ppt/charts/chart21.xml><?xml version="1.0" encoding="utf-8"?>
+<file path=ppt/charts/chart23.xml><?xml version="1.0" encoding="utf-8"?>
 <c:chartSpace xmlns:c="http://schemas.openxmlformats.org/drawingml/2006/chart" xmlns:a="http://schemas.openxmlformats.org/drawingml/2006/main" xmlns:r="http://schemas.openxmlformats.org/officeDocument/2006/relationships">
   <c:date1904 val="0"/>
   <c:roundedCorners val="1"/>
@@ -591,7 +591,7 @@
 </c:chartSpace>
 </file>
 
-<file path=ppt/charts/chart22.xml><?xml version="1.0" encoding="utf-8"?>
+<file path=ppt/charts/chart24.xml><?xml version="1.0" encoding="utf-8"?>
 <c:chartSpace xmlns:c="http://schemas.openxmlformats.org/drawingml/2006/chart" xmlns:a="http://schemas.openxmlformats.org/drawingml/2006/main" xmlns:r="http://schemas.openxmlformats.org/officeDocument/2006/relationships">
   <c:date1904 val="0"/>
   <c:roundedCorners val="1"/>
@@ -1145,7 +1145,7 @@
 </c:chartSpace>
 </file>
 
-<file path=ppt/charts/chart23.xml><?xml version="1.0" encoding="utf-8"?>
+<file path=ppt/charts/chart25.xml><?xml version="1.0" encoding="utf-8"?>
 <c:chartSpace xmlns:c="http://schemas.openxmlformats.org/drawingml/2006/chart" xmlns:a="http://schemas.openxmlformats.org/drawingml/2006/main" xmlns:r="http://schemas.openxmlformats.org/officeDocument/2006/relationships">
   <c:date1904 val="0"/>
   <c:roundedCorners val="1"/>
@@ -1622,7 +1622,7 @@
 </c:chartSpace>
 </file>
 
-<file path=ppt/charts/chart24.xml><?xml version="1.0" encoding="utf-8"?>
+<file path=ppt/charts/chart26.xml><?xml version="1.0" encoding="utf-8"?>
 <c:chartSpace xmlns:c="http://schemas.openxmlformats.org/drawingml/2006/chart" xmlns:a="http://schemas.openxmlformats.org/drawingml/2006/main" xmlns:r="http://schemas.openxmlformats.org/officeDocument/2006/relationships">
   <c:date1904 val="0"/>
   <c:roundedCorners val="1"/>
@@ -1892,7 +1892,7 @@
 </c:chartSpace>
 </file>
 
-<file path=ppt/charts/chart25.xml><?xml version="1.0" encoding="utf-8"?>
+<file path=ppt/charts/chart27.xml><?xml version="1.0" encoding="utf-8"?>
 <c:chartSpace xmlns:c="http://schemas.openxmlformats.org/drawingml/2006/chart" xmlns:a="http://schemas.openxmlformats.org/drawingml/2006/main" xmlns:r="http://schemas.openxmlformats.org/officeDocument/2006/relationships">
   <c:date1904 val="0"/>
   <c:roundedCorners val="1"/>
@@ -2244,7 +2244,7 @@
 </c:chartSpace>
 </file>
 
-<file path=ppt/charts/chart26.xml><?xml version="1.0" encoding="utf-8"?>
+<file path=ppt/charts/chart28.xml><?xml version="1.0" encoding="utf-8"?>
 <c:chartSpace xmlns:c="http://schemas.openxmlformats.org/drawingml/2006/chart" xmlns:a="http://schemas.openxmlformats.org/drawingml/2006/main" xmlns:r="http://schemas.openxmlformats.org/officeDocument/2006/relationships">
   <c:date1904 val="0"/>
   <c:roundedCorners val="1"/>
@@ -2608,7 +2608,7 @@
 </c:chartSpace>
 </file>
 
-<file path=ppt/charts/chart27.xml><?xml version="1.0" encoding="utf-8"?>
+<file path=ppt/charts/chart29.xml><?xml version="1.0" encoding="utf-8"?>
 <c:chartSpace xmlns:c="http://schemas.openxmlformats.org/drawingml/2006/chart" xmlns:a="http://schemas.openxmlformats.org/drawingml/2006/main" xmlns:r="http://schemas.openxmlformats.org/officeDocument/2006/relationships">
   <c:date1904 val="0"/>
   <c:roundedCorners val="1"/>
@@ -2972,7 +2972,7 @@
 </c:chartSpace>
 </file>
 
-<file path=ppt/charts/chart28.xml><?xml version="1.0" encoding="utf-8"?>
+<file path=ppt/charts/chart30.xml><?xml version="1.0" encoding="utf-8"?>
 <c:chartSpace xmlns:c="http://schemas.openxmlformats.org/drawingml/2006/chart" xmlns:a="http://schemas.openxmlformats.org/drawingml/2006/main" xmlns:r="http://schemas.openxmlformats.org/officeDocument/2006/relationships">
   <c:date1904 val="0"/>
   <c:roundedCorners val="1"/>
@@ -3313,7 +3313,7 @@
 </c:chartSpace>
 </file>
 
-<file path=ppt/charts/chart29.xml><?xml version="1.0" encoding="utf-8"?>
+<file path=ppt/charts/chart31.xml><?xml version="1.0" encoding="utf-8"?>
 <c:chartSpace xmlns:c="http://schemas.openxmlformats.org/drawingml/2006/chart" xmlns:a="http://schemas.openxmlformats.org/drawingml/2006/main" xmlns:r="http://schemas.openxmlformats.org/officeDocument/2006/relationships">
   <c:date1904 val="0"/>
   <c:roundedCorners val="1"/>
@@ -3577,7 +3577,7 @@
 </c:chartSpace>
 </file>
 
-<file path=ppt/charts/chart30.xml><?xml version="1.0" encoding="utf-8"?>
+<file path=ppt/charts/chart32.xml><?xml version="1.0" encoding="utf-8"?>
 <c:chartSpace xmlns:c="http://schemas.openxmlformats.org/drawingml/2006/chart" xmlns:a="http://schemas.openxmlformats.org/drawingml/2006/main" xmlns:r="http://schemas.openxmlformats.org/officeDocument/2006/relationships">
   <c:date1904 val="0"/>
   <c:roundedCorners val="1"/>
@@ -3941,7 +3941,7 @@
 </c:chartSpace>
 </file>
 
-<file path=ppt/charts/chart31.xml><?xml version="1.0" encoding="utf-8"?>
+<file path=ppt/charts/chart33.xml><?xml version="1.0" encoding="utf-8"?>
 <c:chartSpace xmlns:c="http://schemas.openxmlformats.org/drawingml/2006/chart" xmlns:a="http://schemas.openxmlformats.org/drawingml/2006/main" xmlns:r="http://schemas.openxmlformats.org/officeDocument/2006/relationships">
   <c:date1904 val="0"/>
   <c:roundedCorners val="1"/>
@@ -29948,7 +29948,7 @@
                 <a:ea typeface="Calibri" pitchFamily="34" charset="-122"/>
                 <a:cs typeface="Calibri" pitchFamily="34" charset="-120"/>
               </a:rPr>
-              <a:t>Hyderabad and Telangana   6–6</a:t>
+              <a:t>Hyderabad and Telangana   6</a:t>
             </a:r>
             <a:endParaRPr lang="en-US" sz="1700" dirty="0"/>
           </a:p>
@@ -30070,7 +30070,7 @@
                 <a:ea typeface="Calibri" pitchFamily="34" charset="-122"/>
                 <a:cs typeface="Calibri" pitchFamily="34" charset="-120"/>
               </a:rPr>
-              <a:t>Limits   18–18</a:t>
+              <a:t>Limits   18</a:t>
             </a:r>
             <a:endParaRPr lang="en-US" sz="1700" dirty="0"/>
           </a:p>
@@ -30090,7 +30090,7 @@
                 <a:ea typeface="Calibri" pitchFamily="34" charset="-122"/>
                 <a:cs typeface="Calibri" pitchFamily="34" charset="-120"/>
               </a:rPr>
-              <a:t>What the Election Commission should do   19–19</a:t>
+              <a:t>What the Election Commission should do   19</a:t>
             </a:r>
             <a:endParaRPr lang="en-US" sz="1700" dirty="0"/>
           </a:p>

</xml_diff>

<commit_message>
Decks: a one-slide section reads as its slide number in the contents (#32)
The contents slide printed a section of one slide as a range, for
example "Hyderabad and Telangana 6–6". It now reads "6". All three decks
are rebuilt and pass validation.

🤖 Generated with [Claude Code](https://claude.com/claude-code)

https://claude.ai/code/session_01FWx24PCx3Jw4SUDQC6oU7o

---
_Generated by [Claude
Code](https://claude.ai/code/session_01FWx24PCx3Jw4SUDQC6oU7o)_

Co-authored-by: Claude <noreply@anthropic.com>
</commit_message>
<xml_diff>
--- a/reports/hyderabad-old-city-sir-2026-deck.pptx
+++ b/reports/hyderabad-old-city-sir-2026-deck.pptx
@@ -127,7 +127,7 @@
 </p:presentation>
 </file>
 
-<file path=ppt/charts/chart21.xml><?xml version="1.0" encoding="utf-8"?>
+<file path=ppt/charts/chart23.xml><?xml version="1.0" encoding="utf-8"?>
 <c:chartSpace xmlns:c="http://schemas.openxmlformats.org/drawingml/2006/chart" xmlns:a="http://schemas.openxmlformats.org/drawingml/2006/main" xmlns:r="http://schemas.openxmlformats.org/officeDocument/2006/relationships">
   <c:date1904 val="0"/>
   <c:roundedCorners val="1"/>
@@ -591,7 +591,7 @@
 </c:chartSpace>
 </file>
 
-<file path=ppt/charts/chart22.xml><?xml version="1.0" encoding="utf-8"?>
+<file path=ppt/charts/chart24.xml><?xml version="1.0" encoding="utf-8"?>
 <c:chartSpace xmlns:c="http://schemas.openxmlformats.org/drawingml/2006/chart" xmlns:a="http://schemas.openxmlformats.org/drawingml/2006/main" xmlns:r="http://schemas.openxmlformats.org/officeDocument/2006/relationships">
   <c:date1904 val="0"/>
   <c:roundedCorners val="1"/>
@@ -1145,7 +1145,7 @@
 </c:chartSpace>
 </file>
 
-<file path=ppt/charts/chart23.xml><?xml version="1.0" encoding="utf-8"?>
+<file path=ppt/charts/chart25.xml><?xml version="1.0" encoding="utf-8"?>
 <c:chartSpace xmlns:c="http://schemas.openxmlformats.org/drawingml/2006/chart" xmlns:a="http://schemas.openxmlformats.org/drawingml/2006/main" xmlns:r="http://schemas.openxmlformats.org/officeDocument/2006/relationships">
   <c:date1904 val="0"/>
   <c:roundedCorners val="1"/>
@@ -1622,7 +1622,7 @@
 </c:chartSpace>
 </file>
 
-<file path=ppt/charts/chart24.xml><?xml version="1.0" encoding="utf-8"?>
+<file path=ppt/charts/chart26.xml><?xml version="1.0" encoding="utf-8"?>
 <c:chartSpace xmlns:c="http://schemas.openxmlformats.org/drawingml/2006/chart" xmlns:a="http://schemas.openxmlformats.org/drawingml/2006/main" xmlns:r="http://schemas.openxmlformats.org/officeDocument/2006/relationships">
   <c:date1904 val="0"/>
   <c:roundedCorners val="1"/>
@@ -1892,7 +1892,7 @@
 </c:chartSpace>
 </file>
 
-<file path=ppt/charts/chart25.xml><?xml version="1.0" encoding="utf-8"?>
+<file path=ppt/charts/chart27.xml><?xml version="1.0" encoding="utf-8"?>
 <c:chartSpace xmlns:c="http://schemas.openxmlformats.org/drawingml/2006/chart" xmlns:a="http://schemas.openxmlformats.org/drawingml/2006/main" xmlns:r="http://schemas.openxmlformats.org/officeDocument/2006/relationships">
   <c:date1904 val="0"/>
   <c:roundedCorners val="1"/>
@@ -2244,7 +2244,7 @@
 </c:chartSpace>
 </file>
 
-<file path=ppt/charts/chart26.xml><?xml version="1.0" encoding="utf-8"?>
+<file path=ppt/charts/chart28.xml><?xml version="1.0" encoding="utf-8"?>
 <c:chartSpace xmlns:c="http://schemas.openxmlformats.org/drawingml/2006/chart" xmlns:a="http://schemas.openxmlformats.org/drawingml/2006/main" xmlns:r="http://schemas.openxmlformats.org/officeDocument/2006/relationships">
   <c:date1904 val="0"/>
   <c:roundedCorners val="1"/>
@@ -2608,7 +2608,7 @@
 </c:chartSpace>
 </file>
 
-<file path=ppt/charts/chart27.xml><?xml version="1.0" encoding="utf-8"?>
+<file path=ppt/charts/chart29.xml><?xml version="1.0" encoding="utf-8"?>
 <c:chartSpace xmlns:c="http://schemas.openxmlformats.org/drawingml/2006/chart" xmlns:a="http://schemas.openxmlformats.org/drawingml/2006/main" xmlns:r="http://schemas.openxmlformats.org/officeDocument/2006/relationships">
   <c:date1904 val="0"/>
   <c:roundedCorners val="1"/>
@@ -2972,7 +2972,7 @@
 </c:chartSpace>
 </file>
 
-<file path=ppt/charts/chart28.xml><?xml version="1.0" encoding="utf-8"?>
+<file path=ppt/charts/chart30.xml><?xml version="1.0" encoding="utf-8"?>
 <c:chartSpace xmlns:c="http://schemas.openxmlformats.org/drawingml/2006/chart" xmlns:a="http://schemas.openxmlformats.org/drawingml/2006/main" xmlns:r="http://schemas.openxmlformats.org/officeDocument/2006/relationships">
   <c:date1904 val="0"/>
   <c:roundedCorners val="1"/>
@@ -3313,7 +3313,7 @@
 </c:chartSpace>
 </file>
 
-<file path=ppt/charts/chart29.xml><?xml version="1.0" encoding="utf-8"?>
+<file path=ppt/charts/chart31.xml><?xml version="1.0" encoding="utf-8"?>
 <c:chartSpace xmlns:c="http://schemas.openxmlformats.org/drawingml/2006/chart" xmlns:a="http://schemas.openxmlformats.org/drawingml/2006/main" xmlns:r="http://schemas.openxmlformats.org/officeDocument/2006/relationships">
   <c:date1904 val="0"/>
   <c:roundedCorners val="1"/>
@@ -3577,7 +3577,7 @@
 </c:chartSpace>
 </file>
 
-<file path=ppt/charts/chart30.xml><?xml version="1.0" encoding="utf-8"?>
+<file path=ppt/charts/chart32.xml><?xml version="1.0" encoding="utf-8"?>
 <c:chartSpace xmlns:c="http://schemas.openxmlformats.org/drawingml/2006/chart" xmlns:a="http://schemas.openxmlformats.org/drawingml/2006/main" xmlns:r="http://schemas.openxmlformats.org/officeDocument/2006/relationships">
   <c:date1904 val="0"/>
   <c:roundedCorners val="1"/>
@@ -3941,7 +3941,7 @@
 </c:chartSpace>
 </file>
 
-<file path=ppt/charts/chart31.xml><?xml version="1.0" encoding="utf-8"?>
+<file path=ppt/charts/chart33.xml><?xml version="1.0" encoding="utf-8"?>
 <c:chartSpace xmlns:c="http://schemas.openxmlformats.org/drawingml/2006/chart" xmlns:a="http://schemas.openxmlformats.org/drawingml/2006/main" xmlns:r="http://schemas.openxmlformats.org/officeDocument/2006/relationships">
   <c:date1904 val="0"/>
   <c:roundedCorners val="1"/>
@@ -29948,7 +29948,7 @@
                 <a:ea typeface="Calibri" pitchFamily="34" charset="-122"/>
                 <a:cs typeface="Calibri" pitchFamily="34" charset="-120"/>
               </a:rPr>
-              <a:t>Hyderabad and Telangana   6–6</a:t>
+              <a:t>Hyderabad and Telangana   6</a:t>
             </a:r>
             <a:endParaRPr lang="en-US" sz="1700" dirty="0"/>
           </a:p>
@@ -30070,7 +30070,7 @@
                 <a:ea typeface="Calibri" pitchFamily="34" charset="-122"/>
                 <a:cs typeface="Calibri" pitchFamily="34" charset="-120"/>
               </a:rPr>
-              <a:t>Limits   18–18</a:t>
+              <a:t>Limits   18</a:t>
             </a:r>
             <a:endParaRPr lang="en-US" sz="1700" dirty="0"/>
           </a:p>
@@ -30090,7 +30090,7 @@
                 <a:ea typeface="Calibri" pitchFamily="34" charset="-122"/>
                 <a:cs typeface="Calibri" pitchFamily="34" charset="-120"/>
               </a:rPr>
-              <a:t>What the Election Commission should do   19–19</a:t>
+              <a:t>What the Election Commission should do   19</a:t>
             </a:r>
             <a:endParaRPr lang="en-US" sz="1700" dirty="0"/>
           </a:p>

</xml_diff>

<commit_message>
Women against the roll, not the 2011 census; plain-language pass; say why five Hyderabad seats
Bihar women's share of the removed is now compared with their share of the
roll before the revision (Format 4B draft roll by sex plus phase 1 removals by
sex), by district and for the state. The finding holds in all 38 districts.
Prose on every page, report and deck rewritten to the owner's style rules;
translations carried where meaning is unchanged, retranslated where it moved.
The Hyderabad pages say the part-level lists were compiled for five seats and
that the other ten appear as the state's totals.

Co-Authored-By: Claude Opus 5.5 <noreply@anthropic.com>
Claude-Session: https://claude.ai/code/session_01FWx24PCx3Jw4SUDQC6oU7o
</commit_message>
<xml_diff>
--- a/reports/hyderabad-old-city-sir-2026-deck.pptx
+++ b/reports/hyderabad-old-city-sir-2026-deck.pptx
@@ -4747,7 +4747,7 @@
           <a:p>
             <a:r>
               <a:rPr lang="en-US" dirty="0"/>
-              <a:t>The lists cover every elector on the pre-revision rolls of the five constituencies, so each group has a true removal rate. These are the September 2026 lists; the final roll is due on 9 November, so restorations after hearings are not in them.</a:t>
+              <a:t>The lists cover every elector on the pre-revision rolls of the five constituencies, so each group has a true removal rate. These are the September 2026 lists and the final roll is due on 9 November, so names put back after hearings are not in them.</a:t>
             </a:r>
             <a:endParaRPr lang="en-US" dirty="0"/>
           </a:p>
@@ -5275,7 +5275,7 @@
           <a:p>
             <a:r>
               <a:rPr lang="en-US" dirty="0"/>
-              <a:t>The Commission extended the calendar on 7 September: claims to 7 October, hearings to 5 November, final roll 9 November. The schedules here are those in the September lists. The length of a slot is not recorded.</a:t>
+              <a:t>On 7 September the Commission extended the calendar, with claims to 7 October, hearings to 5 November and the final roll on 9 November. The schedules here are those in the September lists. The length of a slot is not recorded.</a:t>
             </a:r>
             <a:endParaRPr lang="en-US" dirty="0"/>
           </a:p>
@@ -6067,7 +6067,7 @@
           <a:p>
             <a:r>
               <a:rPr lang="en-US" dirty="0"/>
-              <a:t>No election has been held on the revised roll. The comparison is one of size; the roll records no one's vote.</a:t>
+              <a:t>No election has been held on the revised roll. The comparison is of size only, because the roll records nobody's vote.</a:t>
             </a:r>
             <a:endParaRPr lang="en-US" dirty="0"/>
           </a:p>
@@ -8431,7 +8431,7 @@
                 <a:ea typeface="Calibri" pitchFamily="34" charset="-122"/>
                 <a:cs typeface="Calibri" pitchFamily="34" charset="-120"/>
               </a:rPr>
-              <a:t>Hyderabad Old City SIR 2026 · Varna Sri Raman · aggregates only; no names or EPIC numbers</a:t>
+              <a:t>Hyderabad Old City SIR 2026 · Varna Sri Raman · totals only, never names or EPIC numbers</a:t>
             </a:r>
             <a:endParaRPr lang="en-US" sz="900" dirty="0"/>
           </a:p>
@@ -9535,7 +9535,7 @@
                 <a:ea typeface="Calibri" pitchFamily="34" charset="-122"/>
                 <a:cs typeface="Calibri" pitchFamily="34" charset="-120"/>
               </a:rPr>
-              <a:t>Hyderabad Old City SIR 2026 · Varna Sri Raman · aggregates only; no names or EPIC numbers</a:t>
+              <a:t>Hyderabad Old City SIR 2026 · Varna Sri Raman · totals only, never names or EPIC numbers</a:t>
             </a:r>
             <a:endParaRPr lang="en-US" sz="900" dirty="0"/>
           </a:p>
@@ -11975,7 +11975,7 @@
                 <a:ea typeface="Calibri" pitchFamily="34" charset="-122"/>
                 <a:cs typeface="Calibri" pitchFamily="34" charset="-120"/>
               </a:rPr>
-              <a:t>Hyderabad Old City SIR 2026 · Varna Sri Raman · aggregates only; no names or EPIC numbers</a:t>
+              <a:t>Hyderabad Old City SIR 2026 · Varna Sri Raman · totals only, never names or EPIC numbers</a:t>
             </a:r>
             <a:endParaRPr lang="en-US" sz="900" dirty="0"/>
           </a:p>
@@ -14261,7 +14261,7 @@
                 <a:ea typeface="Calibri" pitchFamily="34" charset="-122"/>
                 <a:cs typeface="Calibri" pitchFamily="34" charset="-120"/>
               </a:rPr>
-              <a:t>Negative: parts with more of that group lost fewer names.</a:t>
+              <a:t>A negative figure means parts with more of that group lost fewer names.</a:t>
             </a:r>
             <a:endParaRPr lang="en-US" sz="1350" dirty="0"/>
           </a:p>
@@ -14303,7 +14303,7 @@
                 <a:ea typeface="Calibri" pitchFamily="34" charset="-122"/>
                 <a:cs typeface="Calibri" pitchFamily="34" charset="-120"/>
               </a:rPr>
-              <a:t>Parts with at least 100 electors; the untraceable share uses parts with at least 20 removals.</a:t>
+              <a:t>Parts with at least 100 electors, and for the untraceable share, parts with at least 20 removals.</a:t>
             </a:r>
             <a:endParaRPr lang="en-US" sz="1350" dirty="0"/>
           </a:p>
@@ -14486,7 +14486,7 @@
                 <a:ea typeface="Calibri" pitchFamily="34" charset="-122"/>
                 <a:cs typeface="Calibri" pitchFamily="34" charset="-120"/>
               </a:rPr>
-              <a:t>Hyderabad Old City SIR 2026 · Varna Sri Raman · aggregates only; no names or EPIC numbers</a:t>
+              <a:t>Hyderabad Old City SIR 2026 · Varna Sri Raman · totals only, never names or EPIC numbers</a:t>
             </a:r>
             <a:endParaRPr lang="en-US" sz="900" dirty="0"/>
           </a:p>
@@ -22102,7 +22102,7 @@
                 <a:ea typeface="Calibri" pitchFamily="34" charset="-122"/>
                 <a:cs typeface="Calibri" pitchFamily="34" charset="-120"/>
               </a:rPr>
-              <a:t>Hyderabad Old City SIR 2026 · Varna Sri Raman · aggregates only; no names or EPIC numbers</a:t>
+              <a:t>Hyderabad Old City SIR 2026 · Varna Sri Raman · totals only, never names or EPIC numbers</a:t>
             </a:r>
             <a:endParaRPr lang="en-US" sz="900" dirty="0"/>
           </a:p>
@@ -23227,7 +23227,7 @@
                 <a:ea typeface="Calibri" pitchFamily="34" charset="-122"/>
                 <a:cs typeface="Calibri" pitchFamily="34" charset="-120"/>
               </a:rPr>
-              <a:t>Hyderabad Old City SIR 2026 · Varna Sri Raman · aggregates only; no names or EPIC numbers</a:t>
+              <a:t>Hyderabad Old City SIR 2026 · Varna Sri Raman · totals only, never names or EPIC numbers</a:t>
             </a:r>
             <a:endParaRPr lang="en-US" sz="900" dirty="0"/>
           </a:p>
@@ -24242,7 +24242,7 @@
                 <a:ea typeface="Calibri" pitchFamily="34" charset="-122"/>
                 <a:cs typeface="Calibri" pitchFamily="34" charset="-120"/>
               </a:rPr>
-              <a:t>Hyderabad Old City SIR 2026 · Varna Sri Raman · aggregates only; no names or EPIC numbers</a:t>
+              <a:t>Hyderabad Old City SIR 2026 · Varna Sri Raman · totals only, never names or EPIC numbers</a:t>
             </a:r>
             <a:endParaRPr lang="en-US" sz="900" dirty="0"/>
           </a:p>
@@ -25167,7 +25167,7 @@
                 <a:ea typeface="Calibri" pitchFamily="34" charset="-122"/>
                 <a:cs typeface="Calibri" pitchFamily="34" charset="-120"/>
               </a:rPr>
-              <a:t>The largest recorded reason is "permanently shifted", 64.2% of removals, and the Old City has a large moving population. But 20.8% were entered as untraceable or absent, 8.7% as dead and 6.0% as enrolled elsewhere. Each is an officer's entry, not a finding.</a:t>
+              <a:t>The largest recorded reason is "permanently shifted", 64.2% of removals, and the Old City has a large moving population. But 20.8% were entered as untraceable or absent, 8.7% as dead and 6.0% as enrolled elsewhere. Each is what the officer wrote down, and nobody checked it.</a:t>
             </a:r>
             <a:endParaRPr lang="en-US" sz="1400" dirty="0"/>
           </a:p>
@@ -25253,7 +25253,7 @@
                 <a:ea typeface="Calibri" pitchFamily="34" charset="-122"/>
                 <a:cs typeface="Calibri" pitchFamily="34" charset="-120"/>
               </a:rPr>
-              <a:t>The lists do not show that. Inside the same polling part, Hindu-name electors were struck off more often than Muslim-name electors. What the lists show is who carried the burden: the old, and those who could not be traced to the 2002 roll.</a:t>
+              <a:t>The lists do not show that. Inside the same polling part, Hindu-name electors were struck off more often than Muslim-name electors. The lists do show who bore the removals, the old and those who could not be traced to the 2002 roll.</a:t>
             </a:r>
             <a:endParaRPr lang="en-US" sz="1400" dirty="0"/>
           </a:p>
@@ -25569,7 +25569,7 @@
                 <a:ea typeface="Calibri" pitchFamily="34" charset="-122"/>
                 <a:cs typeface="Calibri" pitchFamily="34" charset="-120"/>
               </a:rPr>
-              <a:t>Hyderabad Old City SIR 2026 · Varna Sri Raman · aggregates only; no names or EPIC numbers</a:t>
+              <a:t>Hyderabad Old City SIR 2026 · Varna Sri Raman · totals only, never names or EPIC numbers</a:t>
             </a:r>
             <a:endParaRPr lang="en-US" sz="900" dirty="0"/>
           </a:p>
@@ -26896,7 +26896,7 @@
                 <a:ea typeface="Calibri" pitchFamily="34" charset="-122"/>
                 <a:cs typeface="Calibri" pitchFamily="34" charset="-120"/>
               </a:rPr>
-              <a:t>Hyderabad Old City SIR 2026 · Varna Sri Raman · aggregates only; no names or EPIC numbers</a:t>
+              <a:t>Hyderabad Old City SIR 2026 · Varna Sri Raman · totals only, never names or EPIC numbers</a:t>
             </a:r>
             <a:endParaRPr lang="en-US" sz="900" dirty="0"/>
           </a:p>
@@ -27861,7 +27861,7 @@
                 <a:ea typeface="Calibri" pitchFamily="34" charset="-122"/>
                 <a:cs typeface="Calibri" pitchFamily="34" charset="-120"/>
               </a:rPr>
-              <a:t>Whether any single removal was right. A household that moved out is a correct "shifted" deletion; the files cannot tell it from an elector who was at home and missed. Religion and age are given separately, never together.</a:t>
+              <a:t>Whether any single removal was right. A household that moved out is rightly marked "shifted", and the files cannot tell it apart from an elector who was at home when the officer missed them. Religion and age are given separately and never together.</a:t>
             </a:r>
             <a:endParaRPr lang="en-US" sz="1500" dirty="0"/>
           </a:p>
@@ -28049,7 +28049,7 @@
                 <a:ea typeface="Calibri" pitchFamily="34" charset="-122"/>
                 <a:cs typeface="Calibri" pitchFamily="34" charset="-120"/>
               </a:rPr>
-              <a:t>Hyderabad Old City SIR 2026 · Varna Sri Raman · aggregates only; no names or EPIC numbers</a:t>
+              <a:t>Hyderabad Old City SIR 2026 · Varna Sri Raman · totals only, never names or EPIC numbers</a:t>
             </a:r>
             <a:endParaRPr lang="en-US" sz="900" dirty="0"/>
           </a:p>
@@ -28934,7 +28934,7 @@
                 <a:ea typeface="Calibri" pitchFamily="34" charset="-122"/>
                 <a:cs typeface="Calibri" pitchFamily="34" charset="-120"/>
               </a:rPr>
-              <a:t>Record and publish the basis for every removal entered as "untraceable or absent", 1,37,825 names: the visits made and the notice given.</a:t>
+              <a:t>Record and publish the basis for every removal entered as "untraceable or absent", 1,37,825 names in all, including the visits made and the notice given.</a:t>
             </a:r>
             <a:endParaRPr lang="en-US" sz="1700" dirty="0"/>
           </a:p>
@@ -30254,7 +30254,7 @@
                 <a:ea typeface="Calibri" pitchFamily="34" charset="-122"/>
                 <a:cs typeface="Calibri" pitchFamily="34" charset="-120"/>
               </a:rPr>
-              <a:t>Hyderabad Old City SIR 2026 · Varna Sri Raman · aggregates only; no names or EPIC numbers</a:t>
+              <a:t>Hyderabad Old City SIR 2026 · Varna Sri Raman · totals only, never names or EPIC numbers</a:t>
             </a:r>
             <a:endParaRPr lang="en-US" sz="900" dirty="0"/>
           </a:p>
@@ -31138,7 +31138,7 @@
                 <a:ea typeface="Calibri" pitchFamily="34" charset="-122"/>
                 <a:cs typeface="Calibri" pitchFamily="34" charset="-120"/>
               </a:rPr>
-              <a:t>Source: the September 2026 SIR lists for the five constituencies, which record the outcome for every elector on the pre-revision roll: struck off (with the officer's reason), kept but summoned to a hearing (with the rule), or kept.</a:t>
+              <a:t>The source is the September 2026 SIR lists for the five constituencies, compiled for these five seats only. They record the outcome for every elector on the roll before the revision, whether struck off (with the officer's reason), kept but summoned to a hearing (with the rule), or kept.</a:t>
             </a:r>
             <a:endParaRPr lang="en-US" sz="1500" dirty="0"/>
           </a:p>
@@ -31159,7 +31159,7 @@
                 <a:ea typeface="Calibri" pitchFamily="34" charset="-122"/>
                 <a:cs typeface="Calibri" pitchFamily="34" charset="-120"/>
               </a:rPr>
-              <a:t>Removal rate: electors on the absent-shifted-dead list divided by electors on the pre-revision roll, for each group. In Bihar the lists hold only the removed, so the Bihar deck gives shares of removals instead.</a:t>
+              <a:t>The removal rate is the electors on the absent-shifted-dead list divided by the electors on the roll before the revision, for each group. The Bihar lists hold only the removed, so the Bihar deck gives shares of removals.</a:t>
             </a:r>
             <a:endParaRPr lang="en-US" sz="1500" dirty="0"/>
           </a:p>
@@ -31180,7 +31180,7 @@
                 <a:ea typeface="Calibri" pitchFamily="34" charset="-122"/>
                 <a:cs typeface="Calibri" pitchFamily="34" charset="-120"/>
               </a:rPr>
-              <a:t>Within-part difference: one group's rate minus another's inside each polling part, pooled with each part weighted by its smaller group; parts with fewer than 20 of either are left out. This holds the locality and the officer fixed.</a:t>
+              <a:t>The within-part difference is one group's rate minus another's inside each polling part, pooled and weighted by the smaller group in each part. Parts with fewer than 20 of either group are left out. This holds the neighbourhood and the officer constant.</a:t>
             </a:r>
             <a:endParaRPr lang="en-US" sz="1500" dirty="0"/>
           </a:p>
@@ -31222,7 +31222,7 @@
                 <a:ea typeface="Calibri" pitchFamily="34" charset="-122"/>
                 <a:cs typeface="Calibri" pitchFamily="34" charset="-120"/>
               </a:rPr>
-              <a:t>2023 results: the declared Assembly results. Only counts are published: no name, EPIC number or address.</a:t>
+              <a:t>The 2023 results are the declared Assembly results. Only counts are published, never a name, EPIC number or address.</a:t>
             </a:r>
             <a:endParaRPr lang="en-US" sz="1500" dirty="0"/>
           </a:p>
@@ -32338,7 +32338,7 @@
                 <a:ea typeface="Calibri" pitchFamily="34" charset="-122"/>
                 <a:cs typeface="Calibri" pitchFamily="34" charset="-120"/>
               </a:rPr>
-              <a:t>Hyderabad Old City SIR 2026 · Varna Sri Raman · aggregates only; no names or EPIC numbers</a:t>
+              <a:t>Hyderabad Old City SIR 2026 · Varna Sri Raman · totals only, never names or EPIC numbers</a:t>
             </a:r>
             <a:endParaRPr lang="en-US" sz="900" dirty="0"/>
           </a:p>
@@ -33688,7 +33688,7 @@
                 <a:ea typeface="Calibri" pitchFamily="34" charset="-122"/>
                 <a:cs typeface="Calibri" pitchFamily="34" charset="-120"/>
               </a:rPr>
-              <a:t>Hyderabad Old City SIR 2026 · Varna Sri Raman · aggregates only; no names or EPIC numbers</a:t>
+              <a:t>Hyderabad Old City SIR 2026 · Varna Sri Raman · totals only, never names or EPIC numbers</a:t>
             </a:r>
             <a:endParaRPr lang="en-US" sz="900" dirty="0"/>
           </a:p>
@@ -37676,7 +37676,7 @@
                 <a:ea typeface="Calibri" pitchFamily="34" charset="-122"/>
                 <a:cs typeface="Calibri" pitchFamily="34" charset="-120"/>
               </a:rPr>
-              <a:t>Hyderabad Old City SIR 2026 · Varna Sri Raman · aggregates only; no names or EPIC numbers</a:t>
+              <a:t>Hyderabad Old City SIR 2026 · Varna Sri Raman · totals only, never names or EPIC numbers</a:t>
             </a:r>
             <a:endParaRPr lang="en-US" sz="900" dirty="0"/>
           </a:p>
@@ -38618,7 +38618,7 @@
                 <a:ea typeface="Calibri" pitchFamily="34" charset="-122"/>
                 <a:cs typeface="Calibri" pitchFamily="34" charset="-120"/>
               </a:rPr>
-              <a:t>Each reason is an officer's entry, not a finding. An untraceable entry records only that someone was not found.</a:t>
+              <a:t>Each reason is what the officer wrote down, and nobody checked it. An untraceable entry records only that the officer did not find the person.</a:t>
             </a:r>
             <a:endParaRPr lang="en-US" sz="1350" dirty="0"/>
           </a:p>
@@ -38801,7 +38801,7 @@
                 <a:ea typeface="Calibri" pitchFamily="34" charset="-122"/>
                 <a:cs typeface="Calibri" pitchFamily="34" charset="-120"/>
               </a:rPr>
-              <a:t>Hyderabad Old City SIR 2026 · Varna Sri Raman · aggregates only; no names or EPIC numbers</a:t>
+              <a:t>Hyderabad Old City SIR 2026 · Varna Sri Raman · totals only, never names or EPIC numbers</a:t>
             </a:r>
             <a:endParaRPr lang="en-US" sz="900" dirty="0"/>
           </a:p>
@@ -39722,7 +39722,7 @@
                 <a:ea typeface="Calibri" pitchFamily="34" charset="-122"/>
                 <a:cs typeface="Calibri" pitchFamily="34" charset="-120"/>
               </a:rPr>
-              <a:t>The removals follow the capital region, not the Old City.</a:t>
+              <a:t>The removals are heavy across the whole capital region.</a:t>
             </a:r>
             <a:endParaRPr lang="en-US" sz="1350" dirty="0"/>
           </a:p>
@@ -39743,7 +39743,7 @@
                 <a:ea typeface="Calibri" pitchFamily="34" charset="-122"/>
                 <a:cs typeface="Calibri" pitchFamily="34" charset="-120"/>
               </a:rPr>
-              <a:t>The state publishes totals only below the district: no split by reason.</a:t>
+              <a:t>Below the district the state publishes totals only, with no split by reason.</a:t>
             </a:r>
             <a:endParaRPr lang="en-US" sz="1350" dirty="0"/>
           </a:p>
@@ -39926,7 +39926,7 @@
                 <a:ea typeface="Calibri" pitchFamily="34" charset="-122"/>
                 <a:cs typeface="Calibri" pitchFamily="34" charset="-120"/>
               </a:rPr>
-              <a:t>Hyderabad Old City SIR 2026 · Varna Sri Raman · aggregates only; no names or EPIC numbers</a:t>
+              <a:t>Hyderabad Old City SIR 2026 · Varna Sri Raman · totals only, never names or EPIC numbers</a:t>
             </a:r>
             <a:endParaRPr lang="en-US" sz="900" dirty="0"/>
           </a:p>
@@ -41051,7 +41051,7 @@
                 <a:ea typeface="Calibri" pitchFamily="34" charset="-122"/>
                 <a:cs typeface="Calibri" pitchFamily="34" charset="-120"/>
               </a:rPr>
-              <a:t>Hyderabad Old City SIR 2026 · Varna Sri Raman · aggregates only; no names or EPIC numbers</a:t>
+              <a:t>Hyderabad Old City SIR 2026 · Varna Sri Raman · totals only, never names or EPIC numbers</a:t>
             </a:r>
             <a:endParaRPr lang="en-US" sz="900" dirty="0"/>
           </a:p>
@@ -42176,7 +42176,7 @@
                 <a:ea typeface="Calibri" pitchFamily="34" charset="-122"/>
                 <a:cs typeface="Calibri" pitchFamily="34" charset="-120"/>
               </a:rPr>
-              <a:t>Hyderabad Old City SIR 2026 · Varna Sri Raman · aggregates only; no names or EPIC numbers</a:t>
+              <a:t>Hyderabad Old City SIR 2026 · Varna Sri Raman · totals only, never names or EPIC numbers</a:t>
             </a:r>
             <a:endParaRPr lang="en-US" sz="900" dirty="0"/>
           </a:p>
@@ -43118,7 +43118,7 @@
                 <a:ea typeface="Calibri" pitchFamily="34" charset="-122"/>
                 <a:cs typeface="Calibri" pitchFamily="34" charset="-120"/>
               </a:rPr>
-              <a:t>Religion is estimated from names; the roll records none.</a:t>
+              <a:t>Religion is guessed from names, because the roll does not record it.</a:t>
             </a:r>
             <a:endParaRPr lang="en-US" sz="1400" dirty="0"/>
           </a:p>

</xml_diff>

<commit_message>
Lead with what was lost; How sure are we; no dashboard banners
Summaries, FAQ answers, key insights and deck titles now open with the
scale of the removals, the seats where the removed could have changed the
result, and who was removed. Facts that cut the other way stay in the body as
plain facts. A new robustness build (scripts/build_robust.py) puts each Bihar
finding through within-district, within-seat and leave-out-Seemanchal checks,
shown as How sure are we? on the Elections page, in the report and in the
deck. The dashboards' per-tab banners are plain paragraphs, and the Overview
banner that repeated the summary is gone. Reports and decks rebuilt.

Co-Authored-By: Claude Opus 5.5 <noreply@anthropic.com>
Claude-Session: https://claude.ai/code/session_01FWx24PCx3Jw4SUDQC6oU7o
</commit_message>
<xml_diff>
--- a/reports/hyderabad-old-city-sir-2026-deck.pptx
+++ b/reports/hyderabad-old-city-sir-2026-deck.pptx
@@ -27798,7 +27798,7 @@
                 <a:ea typeface="Calibri" pitchFamily="34" charset="-122"/>
                 <a:cs typeface="Calibri" pitchFamily="34" charset="-120"/>
               </a:rPr>
-              <a:t>How many electors were struck off, from which parts, and who they were by age, sex, religion estimated from names, and link to the 2002 roll. Because the lists hold every elector, each group has a true removal rate.</a:t>
+              <a:t>How many electors were struck off, from which parts, and who they were by age, sex, religion guessed from names, and link to the 2002 roll. Because the lists hold every elector, each group has a true removal rate.</a:t>
             </a:r>
             <a:endParaRPr lang="en-US" sz="1500" dirty="0"/>
           </a:p>
@@ -38723,7 +38723,7 @@
                 <a:ea typeface="Cambria" pitchFamily="34" charset="-122"/>
                 <a:cs typeface="Cambria" pitchFamily="34" charset="-120"/>
               </a:rPr>
-              <a:t>The Old City seats lost 39.9% of their roll, Hyderabad's other ten seats 41.6%</a:t>
+              <a:t>Hyderabad lost 41.0% of its roll, more than twice the 18.6% in the rest of Telangana</a:t>
             </a:r>
             <a:endParaRPr lang="en-US" sz="2700" dirty="0"/>
           </a:p>
@@ -42137,7 +42137,7 @@
                 <a:ea typeface="Calibri" pitchFamily="34" charset="-122"/>
                 <a:cs typeface="Calibri" pitchFamily="34" charset="-120"/>
               </a:rPr>
-              <a:t>Share struck off by religion estimated from names, constituency by constituency</a:t>
+              <a:t>Share struck off by religion guessed from names, constituency by constituency</a:t>
             </a:r>
             <a:endParaRPr lang="en-US" sz="1400" dirty="0"/>
           </a:p>

</xml_diff>

<commit_message>
Stop comparing Bihar and Hyderabad
Drop the Hyderabad-Bihar comparison question, the Bihar women's figure and
the Bihar method notes from the Hyderabad method page, and the matching lines
from both reports and the Hyderabad deck. Reports and decks rebuilt.

Co-Authored-By: Claude Opus 5.5 <noreply@anthropic.com>
Claude-Session: https://claude.ai/code/session_01FWx24PCx3Jw4SUDQC6oU7o
</commit_message>
<xml_diff>
--- a/reports/hyderabad-old-city-sir-2026-deck.pptx
+++ b/reports/hyderabad-old-city-sir-2026-deck.pptx
@@ -9335,27 +9335,6 @@
             </a:r>
             <a:endParaRPr lang="en-US" sz="1400" dirty="0"/>
           </a:p>
-          <a:p>
-            <a:pPr marL="342900" indent="-342900">
-              <a:spcAft>
-                <a:spcPts val="800"/>
-              </a:spcAft>
-              <a:buSzPct val="100000"/>
-              <a:buChar char="•"/>
-            </a:pPr>
-            <a:r>
-              <a:rPr lang="en-US" sz="1400" dirty="0">
-                <a:solidFill>
-                  <a:srgbClr val="1C2833"/>
-                </a:solidFill>
-                <a:latin typeface="Calibri" pitchFamily="34" charset="0"/>
-                <a:ea typeface="Calibri" pitchFamily="34" charset="-122"/>
-                <a:cs typeface="Calibri" pitchFamily="34" charset="-120"/>
-              </a:rPr>
-              <a:t>In Bihar, women were 55.5% of the removed. The Old City shows no such gap.</a:t>
-            </a:r>
-            <a:endParaRPr lang="en-US" sz="1400" dirty="0"/>
-          </a:p>
         </p:txBody>
       </p:sp>
     </p:spTree>
@@ -31159,7 +31138,7 @@
                 <a:ea typeface="Calibri" pitchFamily="34" charset="-122"/>
                 <a:cs typeface="Calibri" pitchFamily="34" charset="-120"/>
               </a:rPr>
-              <a:t>The removal rate is the electors on the absent-shifted-dead list divided by the electors on the roll before the revision, for each group. The Bihar lists hold only the removed, so the Bihar deck gives shares of removals.</a:t>
+              <a:t>The removal rate is the electors on the absent-shifted-dead list divided by the electors on the roll before the revision, for each group.</a:t>
             </a:r>
             <a:endParaRPr lang="en-US" sz="1500" dirty="0"/>
           </a:p>

</xml_diff>

<commit_message>
Stop comparing Bihar and Hyderabad (#45)
- Hyderabad method page: removed the question "How does Hyderabad
compare with Bihar?", the Bihar women's figure in the sex answer, and
the two method notes that pointed to Bihar. The page no longer loads
Bihar data.
- Bihar report: dropped the "nine per hundred against forty" sentence.
- Hyderabad report and deck: dropped the Bihar women's line and the note
on Bihar's lists.
- Reports and decks rebuilt, and the decks validated. The three
translations were updated, and 15 stale translations were pruned.
- CLAUDE.md now says the two analyses are never compared.

Checks: check_data passes 20 checks, and check_i18n passes.

🤖 Generated with [Claude Code](https://claude.com/claude-code)

https://claude.ai/code/session_01FWx24PCx3Jw4SUDQC6oU7o

---
_Generated by [Claude
Code](https://claude.ai/code/session_01FWx24PCx3Jw4SUDQC6oU7o)_

Co-authored-by: Claude <noreply@anthropic.com>
</commit_message>
<xml_diff>
--- a/reports/hyderabad-old-city-sir-2026-deck.pptx
+++ b/reports/hyderabad-old-city-sir-2026-deck.pptx
@@ -9335,27 +9335,6 @@
             </a:r>
             <a:endParaRPr lang="en-US" sz="1400" dirty="0"/>
           </a:p>
-          <a:p>
-            <a:pPr marL="342900" indent="-342900">
-              <a:spcAft>
-                <a:spcPts val="800"/>
-              </a:spcAft>
-              <a:buSzPct val="100000"/>
-              <a:buChar char="•"/>
-            </a:pPr>
-            <a:r>
-              <a:rPr lang="en-US" sz="1400" dirty="0">
-                <a:solidFill>
-                  <a:srgbClr val="1C2833"/>
-                </a:solidFill>
-                <a:latin typeface="Calibri" pitchFamily="34" charset="0"/>
-                <a:ea typeface="Calibri" pitchFamily="34" charset="-122"/>
-                <a:cs typeface="Calibri" pitchFamily="34" charset="-120"/>
-              </a:rPr>
-              <a:t>In Bihar, women were 55.5% of the removed. The Old City shows no such gap.</a:t>
-            </a:r>
-            <a:endParaRPr lang="en-US" sz="1400" dirty="0"/>
-          </a:p>
         </p:txBody>
       </p:sp>
     </p:spTree>
@@ -31159,7 +31138,7 @@
                 <a:ea typeface="Calibri" pitchFamily="34" charset="-122"/>
                 <a:cs typeface="Calibri" pitchFamily="34" charset="-120"/>
               </a:rPr>
-              <a:t>The removal rate is the electors on the absent-shifted-dead list divided by the electors on the roll before the revision, for each group. The Bihar lists hold only the removed, so the Bihar deck gives shares of removals.</a:t>
+              <a:t>The removal rate is the electors on the absent-shifted-dead list divided by the electors on the roll before the revision, for each group.</a:t>
             </a:r>
             <a:endParaRPr lang="en-US" sz="1500" dirty="0"/>
           </a:p>

</xml_diff>

<commit_message>
All India report and deck: against the winning margins, the roll over forty years, how the revision was run
Co-Authored-By: Claude Opus 5.5 <noreply@anthropic.com>
Claude-Session: https://claude.ai/code/session_01FWx24PCx3Jw4SUDQC6oU7o
</commit_message>
<xml_diff>
--- a/reports/hyderabad-old-city-sir-2026-deck.pptx
+++ b/reports/hyderabad-old-city-sir-2026-deck.pptx
@@ -127,7 +127,7 @@
 </p:presentation>
 </file>
 
-<file path=ppt/charts/chart23.xml><?xml version="1.0" encoding="utf-8"?>
+<file path=ppt/charts/chart25.xml><?xml version="1.0" encoding="utf-8"?>
 <c:chartSpace xmlns:c="http://schemas.openxmlformats.org/drawingml/2006/chart" xmlns:a="http://schemas.openxmlformats.org/drawingml/2006/main" xmlns:r="http://schemas.openxmlformats.org/officeDocument/2006/relationships">
   <c:date1904 val="0"/>
   <c:roundedCorners val="1"/>
@@ -591,7 +591,7 @@
 </c:chartSpace>
 </file>
 
-<file path=ppt/charts/chart24.xml><?xml version="1.0" encoding="utf-8"?>
+<file path=ppt/charts/chart26.xml><?xml version="1.0" encoding="utf-8"?>
 <c:chartSpace xmlns:c="http://schemas.openxmlformats.org/drawingml/2006/chart" xmlns:a="http://schemas.openxmlformats.org/drawingml/2006/main" xmlns:r="http://schemas.openxmlformats.org/officeDocument/2006/relationships">
   <c:date1904 val="0"/>
   <c:roundedCorners val="1"/>
@@ -1145,7 +1145,7 @@
 </c:chartSpace>
 </file>
 
-<file path=ppt/charts/chart25.xml><?xml version="1.0" encoding="utf-8"?>
+<file path=ppt/charts/chart27.xml><?xml version="1.0" encoding="utf-8"?>
 <c:chartSpace xmlns:c="http://schemas.openxmlformats.org/drawingml/2006/chart" xmlns:a="http://schemas.openxmlformats.org/drawingml/2006/main" xmlns:r="http://schemas.openxmlformats.org/officeDocument/2006/relationships">
   <c:date1904 val="0"/>
   <c:roundedCorners val="1"/>
@@ -1622,7 +1622,7 @@
 </c:chartSpace>
 </file>
 
-<file path=ppt/charts/chart26.xml><?xml version="1.0" encoding="utf-8"?>
+<file path=ppt/charts/chart28.xml><?xml version="1.0" encoding="utf-8"?>
 <c:chartSpace xmlns:c="http://schemas.openxmlformats.org/drawingml/2006/chart" xmlns:a="http://schemas.openxmlformats.org/drawingml/2006/main" xmlns:r="http://schemas.openxmlformats.org/officeDocument/2006/relationships">
   <c:date1904 val="0"/>
   <c:roundedCorners val="1"/>
@@ -1892,7 +1892,7 @@
 </c:chartSpace>
 </file>
 
-<file path=ppt/charts/chart27.xml><?xml version="1.0" encoding="utf-8"?>
+<file path=ppt/charts/chart29.xml><?xml version="1.0" encoding="utf-8"?>
 <c:chartSpace xmlns:c="http://schemas.openxmlformats.org/drawingml/2006/chart" xmlns:a="http://schemas.openxmlformats.org/drawingml/2006/main" xmlns:r="http://schemas.openxmlformats.org/officeDocument/2006/relationships">
   <c:date1904 val="0"/>
   <c:roundedCorners val="1"/>
@@ -2244,7 +2244,7 @@
 </c:chartSpace>
 </file>
 
-<file path=ppt/charts/chart28.xml><?xml version="1.0" encoding="utf-8"?>
+<file path=ppt/charts/chart30.xml><?xml version="1.0" encoding="utf-8"?>
 <c:chartSpace xmlns:c="http://schemas.openxmlformats.org/drawingml/2006/chart" xmlns:a="http://schemas.openxmlformats.org/drawingml/2006/main" xmlns:r="http://schemas.openxmlformats.org/officeDocument/2006/relationships">
   <c:date1904 val="0"/>
   <c:roundedCorners val="1"/>
@@ -2608,7 +2608,7 @@
 </c:chartSpace>
 </file>
 
-<file path=ppt/charts/chart29.xml><?xml version="1.0" encoding="utf-8"?>
+<file path=ppt/charts/chart31.xml><?xml version="1.0" encoding="utf-8"?>
 <c:chartSpace xmlns:c="http://schemas.openxmlformats.org/drawingml/2006/chart" xmlns:a="http://schemas.openxmlformats.org/drawingml/2006/main" xmlns:r="http://schemas.openxmlformats.org/officeDocument/2006/relationships">
   <c:date1904 val="0"/>
   <c:roundedCorners val="1"/>
@@ -2972,7 +2972,7 @@
 </c:chartSpace>
 </file>
 
-<file path=ppt/charts/chart30.xml><?xml version="1.0" encoding="utf-8"?>
+<file path=ppt/charts/chart32.xml><?xml version="1.0" encoding="utf-8"?>
 <c:chartSpace xmlns:c="http://schemas.openxmlformats.org/drawingml/2006/chart" xmlns:a="http://schemas.openxmlformats.org/drawingml/2006/main" xmlns:r="http://schemas.openxmlformats.org/officeDocument/2006/relationships">
   <c:date1904 val="0"/>
   <c:roundedCorners val="1"/>
@@ -3313,7 +3313,7 @@
 </c:chartSpace>
 </file>
 
-<file path=ppt/charts/chart31.xml><?xml version="1.0" encoding="utf-8"?>
+<file path=ppt/charts/chart33.xml><?xml version="1.0" encoding="utf-8"?>
 <c:chartSpace xmlns:c="http://schemas.openxmlformats.org/drawingml/2006/chart" xmlns:a="http://schemas.openxmlformats.org/drawingml/2006/main" xmlns:r="http://schemas.openxmlformats.org/officeDocument/2006/relationships">
   <c:date1904 val="0"/>
   <c:roundedCorners val="1"/>
@@ -3577,7 +3577,7 @@
 </c:chartSpace>
 </file>
 
-<file path=ppt/charts/chart32.xml><?xml version="1.0" encoding="utf-8"?>
+<file path=ppt/charts/chart34.xml><?xml version="1.0" encoding="utf-8"?>
 <c:chartSpace xmlns:c="http://schemas.openxmlformats.org/drawingml/2006/chart" xmlns:a="http://schemas.openxmlformats.org/drawingml/2006/main" xmlns:r="http://schemas.openxmlformats.org/officeDocument/2006/relationships">
   <c:date1904 val="0"/>
   <c:roundedCorners val="1"/>
@@ -3941,7 +3941,7 @@
 </c:chartSpace>
 </file>
 
-<file path=ppt/charts/chart33.xml><?xml version="1.0" encoding="utf-8"?>
+<file path=ppt/charts/chart35.xml><?xml version="1.0" encoding="utf-8"?>
 <c:chartSpace xmlns:c="http://schemas.openxmlformats.org/drawingml/2006/chart" xmlns:a="http://schemas.openxmlformats.org/drawingml/2006/main" xmlns:r="http://schemas.openxmlformats.org/officeDocument/2006/relationships">
   <c:date1904 val="0"/>
   <c:roundedCorners val="1"/>

</xml_diff>

<commit_message>
Writing sweep, work in progress
Co-Authored-By: Claude Opus 5.5 <noreply@anthropic.com>
Claude-Session: https://claude.ai/code/session_01FWx24PCx3Jw4SUDQC6oU7o
</commit_message>
<xml_diff>
--- a/reports/hyderabad-old-city-sir-2026-deck.pptx
+++ b/reports/hyderabad-old-city-sir-2026-deck.pptx
@@ -3598,7 +3598,7 @@
               <c:strCache>
                 <c:ptCount val="1"/>
                 <c:pt idx="0">
-                  <c:v>Median cases per slot</c:v>
+                  <c:v>Cases in the typical slot (median)</c:v>
                 </c:pt>
               </c:strCache>
             </c:strRef>
@@ -4747,7 +4747,7 @@
           <a:p>
             <a:r>
               <a:rPr lang="en-US" dirty="0"/>
-              <a:t>The lists cover every elector on the pre-revision rolls of the five constituencies, so each group has a true removal rate. These are the September 2026 lists and the final roll is due on 9 November, so names put back after hearings are not in them.</a:t>
+              <a:t>The Special Intensive Revision (SIR) is the Election Commission's house-to-house recheck of the electoral roll. The lists cover every elector on the rolls of the five constituencies before the revision, so each group has a true removal rate, the share of its own members struck off. These are the September 2026 lists. The final roll is due on 9 November, so names put back after hearings are not in them.</a:t>
             </a:r>
             <a:endParaRPr lang="en-US" dirty="0"/>
           </a:p>
@@ -5011,7 +5011,7 @@
           <a:p>
             <a:r>
               <a:rPr lang="en-US" dirty="0"/>
-              <a:t/>
+              <a:t>A polling part is the section of the roll served by one polling station. A rank correlation runs from -1 to 1 and measures how far two orderings of the parts agree.</a:t>
             </a:r>
             <a:endParaRPr lang="en-US" dirty="0"/>
           </a:p>
@@ -6067,7 +6067,7 @@
           <a:p>
             <a:r>
               <a:rPr lang="en-US" dirty="0"/>
-              <a:t>No election has been held on the revised roll. The comparison is of size only, because the roll records nobody's vote.</a:t>
+              <a:t>The winning margin is the winner's votes less the runner-up's. No election has been held on the revised roll. The comparison is of size only, because the roll records nobody's vote.</a:t>
             </a:r>
             <a:endParaRPr lang="en-US" dirty="0"/>
           </a:p>
@@ -7097,7 +7097,7 @@
                 <a:ea typeface="Calibri" pitchFamily="34" charset="-122"/>
                 <a:cs typeface="Calibri" pitchFamily="34" charset="-120"/>
               </a:rPr>
-              <a:t>electors struck off the pre-revision rolls</a:t>
+              <a:t>electors struck off the rolls before the revision</a:t>
             </a:r>
             <a:endParaRPr lang="en-US" sz="1250" dirty="0"/>
           </a:p>
@@ -9475,7 +9475,7 @@
                 <a:ea typeface="Calibri" pitchFamily="34" charset="-122"/>
                 <a:cs typeface="Calibri" pitchFamily="34" charset="-120"/>
               </a:rPr>
-              <a:t>Polling parts with at least 100 electors, by the share struck off; Malakpet has no part numbers</a:t>
+              <a:t>Polling parts with at least 100 electors, by the share struck off. Malakpet has no part numbers</a:t>
             </a:r>
             <a:endParaRPr lang="en-US" sz="1400" dirty="0"/>
           </a:p>
@@ -10557,7 +10557,7 @@
                           <a:ea typeface="Calibri" pitchFamily="34" charset="-122"/>
                           <a:cs typeface="Calibri" pitchFamily="34" charset="-120"/>
                         </a:rPr>
-                        <a:t>Median</a:t>
+                        <a:t>Middle</a:t>
                       </a:r>
                       <a:endParaRPr lang="en-US" sz="1300" dirty="0">
                         <a:latin typeface="Calibri" charset="0"/>
@@ -14203,7 +14203,7 @@
       </p:graphicFrame>
       <p:sp>
         <p:nvSpPr>
-          <p:cNvPr id="48" name="Text 45"/>
+          <p:cNvPr id="49" name="Text 45"/>
           <p:cNvSpPr txBox="1"/>
           <p:nvPr/>
         </p:nvSpPr>
@@ -22981,7 +22981,7 @@
                 <a:ea typeface="Calibri" pitchFamily="34" charset="-122"/>
                 <a:cs typeface="Calibri" pitchFamily="34" charset="-120"/>
               </a:rPr>
-              <a:t>31.6% of flags were for not being traced to the last intensive revision, in 2002; mismatched names came next.</a:t>
+              <a:t>31.6% of flags were for not being traced to the last intensive revision, in 2002. Mismatched names came next.</a:t>
             </a:r>
             <a:endParaRPr lang="en-US" sz="1400" dirty="0"/>
           </a:p>
@@ -23128,7 +23128,7 @@
                 <a:ea typeface="Cambria" pitchFamily="34" charset="-122"/>
                 <a:cs typeface="Cambria" pitchFamily="34" charset="-120"/>
               </a:rPr>
-              <a:t>The busiest hearing slot listed 459 cases; the median slot in Charminar listed 38</a:t>
+              <a:t>The busiest hearing slot listed 459 cases, and the typical slot in Charminar listed 38</a:t>
             </a:r>
             <a:endParaRPr lang="en-US" sz="2700" dirty="0"/>
           </a:p>
@@ -26473,7 +26473,7 @@
                 <a:ea typeface="Calibri" pitchFamily="34" charset="-122"/>
                 <a:cs typeface="Calibri" pitchFamily="34" charset="-120"/>
               </a:rPr>
-              <a:t>3,69,972 electors kept on the draft roll were summoned. The busiest single slot listed 459 cases, in Charminar, where the median slot listed 38. The lists do not record how long a slot was.</a:t>
+              <a:t>3,69,972 electors kept on the draft roll were summoned. The busiest single slot listed 459 cases, in Charminar, where the typical slot listed 38. The lists do not record how long a slot was.</a:t>
             </a:r>
             <a:endParaRPr lang="en-US" sz="1400" dirty="0"/>
           </a:p>
@@ -26645,7 +26645,7 @@
                 <a:ea typeface="Calibri" pitchFamily="34" charset="-122"/>
                 <a:cs typeface="Calibri" pitchFamily="34" charset="-120"/>
               </a:rPr>
-              <a:t>For four constituencies the counts agree exactly with an independent count of the same lists, as do the recorded reasons and women's share. The Malakpet list used here is incomplete: 1,42,688 names against 1,47,799 in the published list, with no part numbers or 2002 link.</a:t>
+              <a:t>For four constituencies the counts agree exactly with an independent count of the same lists, as do the recorded reasons and women's share. The Malakpet list used here is incomplete, with 1,42,688 names against 1,47,799 in the published list and no part numbers or 2002 link.</a:t>
             </a:r>
             <a:endParaRPr lang="en-US" sz="1400" dirty="0"/>
           </a:p>
@@ -31180,7 +31180,7 @@
                 <a:ea typeface="Calibri" pitchFamily="34" charset="-122"/>
                 <a:cs typeface="Calibri" pitchFamily="34" charset="-120"/>
               </a:rPr>
-              <a:t>Part correlations: Spearman rank correlations across parts with at least 100 electors, within each constituency.</a:t>
+              <a:t>Part correlations are Spearman rank correlations, which compare orderings only, across parts with at least 100 electors within each constituency.</a:t>
             </a:r>
             <a:endParaRPr lang="en-US" sz="1500" dirty="0"/>
           </a:p>
@@ -32278,7 +32278,7 @@
                 <a:ea typeface="Calibri" pitchFamily="34" charset="-122"/>
                 <a:cs typeface="Calibri" pitchFamily="34" charset="-120"/>
               </a:rPr>
-              <a:t>What happened to each elector on the five pre-revision rolls, % of the roll</a:t>
+              <a:t>What happened to each elector on the five rolls before the revision, as a % of the roll</a:t>
             </a:r>
             <a:endParaRPr lang="en-US" sz="1400" dirty="0"/>
           </a:p>
@@ -39680,7 +39680,7 @@
                 <a:ea typeface="Calibri" pitchFamily="34" charset="-122"/>
                 <a:cs typeface="Calibri" pitchFamily="34" charset="-120"/>
               </a:rPr>
-              <a:t>Hyderabad district: 41.0%. The rest of Telangana: 18.6%.</a:t>
+              <a:t>Hyderabad district lost 41.0% of its roll, and the rest of Telangana 18.6%.</a:t>
             </a:r>
             <a:endParaRPr lang="en-US" sz="1350" dirty="0"/>
           </a:p>
@@ -40805,7 +40805,7 @@
                 <a:ea typeface="Calibri" pitchFamily="34" charset="-122"/>
                 <a:cs typeface="Calibri" pitchFamily="34" charset="-120"/>
               </a:rPr>
-              <a:t>The pattern holds in every constituency: 70.1% to 76.6% of those aged 80 and over, 19.3% to 25.6% of those aged 18 to 24.</a:t>
+              <a:t>The pattern holds in every constituency, from 70.1% to 76.6% of those aged 80 and over and 19.3% to 25.6% of those aged 18 to 24.</a:t>
             </a:r>
             <a:endParaRPr lang="en-US" sz="1400" dirty="0"/>
           </a:p>
@@ -40991,7 +40991,7 @@
                 <a:ea typeface="Calibri" pitchFamily="34" charset="-122"/>
                 <a:cs typeface="Calibri" pitchFamily="34" charset="-120"/>
               </a:rPr>
-              <a:t>Share struck off, by whether the elector maps to the 2002 intensive revision roll. Malakpet's list carries no link.</a:t>
+              <a:t>Share struck off, by whether the elector can be traced to the roll of the 2002 intensive revision. Malakpet's list carries no link.</a:t>
             </a:r>
             <a:endParaRPr lang="en-US" sz="1400" dirty="0"/>
           </a:p>
@@ -41930,7 +41930,7 @@
                 <a:ea typeface="Calibri" pitchFamily="34" charset="-122"/>
                 <a:cs typeface="Calibri" pitchFamily="34" charset="-120"/>
               </a:rPr>
-              <a:t>Linked electors: 25.3% struck off. No link: 51.6%.</a:t>
+              <a:t>25.3% of linked electors were struck off, and 51.6% of those with no link.</a:t>
             </a:r>
             <a:endParaRPr lang="en-US" sz="1400" dirty="0"/>
           </a:p>
@@ -41972,7 +41972,7 @@
                 <a:ea typeface="Calibri" pitchFamily="34" charset="-122"/>
                 <a:cs typeface="Calibri" pitchFamily="34" charset="-120"/>
               </a:rPr>
-              <a:t>The 2002 link is the revision's own test. Anyone who moved to the city after 2002, or whose family name is spelt differently on the old roll, starts behind.</a:t>
+              <a:t>The revision asks every elector to show a link to the 2002 roll. Anyone who moved to the city after 2002, or whose family name is spelt differently on the old roll, starts behind.</a:t>
             </a:r>
             <a:endParaRPr lang="en-US" sz="1400" dirty="0"/>
           </a:p>

</xml_diff>

<commit_message>
Rebuild reports, decks and preview cards; burdens sentence reads well when every state agrees; document rounding and caste sources
Co-Authored-By: Claude Opus 5.5 <noreply@anthropic.com>
Claude-Session: https://claude.ai/code/session_01FWx24PCx3Jw4SUDQC6oU7o
</commit_message>
<xml_diff>
--- a/reports/hyderabad-old-city-sir-2026-deck.pptx
+++ b/reports/hyderabad-old-city-sir-2026-deck.pptx
@@ -217,19 +217,19 @@
                 <c:formatCode>General</c:formatCode>
                 <c:ptCount val="5"/>
                 <c:pt idx="0">
-                  <c:v>39.66</c:v>
+                  <c:v>39.655</c:v>
                 </c:pt>
                 <c:pt idx="1">
-                  <c:v>41.33</c:v>
+                  <c:v>41.3343</c:v>
                 </c:pt>
                 <c:pt idx="2">
-                  <c:v>45.09</c:v>
+                  <c:v>45.0896</c:v>
                 </c:pt>
                 <c:pt idx="3">
-                  <c:v>39.46</c:v>
+                  <c:v>39.4565</c:v>
                 </c:pt>
                 <c:pt idx="4">
-                  <c:v>34.57</c:v>
+                  <c:v>34.5704</c:v>
                 </c:pt>
               </c:numCache>
             </c:numRef>
@@ -313,19 +313,19 @@
                 <c:formatCode>General</c:formatCode>
                 <c:ptCount val="5"/>
                 <c:pt idx="0">
-                  <c:v>21.12</c:v>
+                  <c:v>21.1249</c:v>
                 </c:pt>
                 <c:pt idx="1">
-                  <c:v>23.3</c:v>
+                  <c:v>23.3011</c:v>
                 </c:pt>
                 <c:pt idx="2">
-                  <c:v>21.55</c:v>
+                  <c:v>21.5475</c:v>
                 </c:pt>
                 <c:pt idx="3">
-                  <c:v>21.27</c:v>
+                  <c:v>21.2685</c:v>
                 </c:pt>
                 <c:pt idx="4">
-                  <c:v>23.93</c:v>
+                  <c:v>23.9309</c:v>
                 </c:pt>
               </c:numCache>
             </c:numRef>
@@ -1429,49 +1429,49 @@
                 <c:formatCode>General</c:formatCode>
                 <c:ptCount val="15"/>
                 <c:pt idx="0">
-                  <c:v>34.57</c:v>
+                  <c:v>34.5704</c:v>
                 </c:pt>
                 <c:pt idx="1">
-                  <c:v>37</c:v>
+                  <c:v>36.9963</c:v>
                 </c:pt>
                 <c:pt idx="2">
-                  <c:v>38.19</c:v>
+                  <c:v>38.1891</c:v>
                 </c:pt>
                 <c:pt idx="3">
-                  <c:v>39.46</c:v>
+                  <c:v>39.4564</c:v>
                 </c:pt>
                 <c:pt idx="4">
-                  <c:v>39.64</c:v>
+                  <c:v>39.6387</c:v>
                 </c:pt>
                 <c:pt idx="5">
-                  <c:v>39.66</c:v>
+                  <c:v>39.655</c:v>
                 </c:pt>
                 <c:pt idx="6">
-                  <c:v>40.02</c:v>
+                  <c:v>40.0235</c:v>
                 </c:pt>
                 <c:pt idx="7">
-                  <c:v>41.33</c:v>
+                  <c:v>41.3343</c:v>
                 </c:pt>
                 <c:pt idx="8">
-                  <c:v>42.04</c:v>
+                  <c:v>42.0449</c:v>
                 </c:pt>
                 <c:pt idx="9">
-                  <c:v>42.61</c:v>
+                  <c:v>42.6132</c:v>
                 </c:pt>
                 <c:pt idx="10">
-                  <c:v>42.77</c:v>
+                  <c:v>42.7699</c:v>
                 </c:pt>
                 <c:pt idx="11">
-                  <c:v>44.14</c:v>
+                  <c:v>44.135</c:v>
                 </c:pt>
                 <c:pt idx="12">
-                  <c:v>44.76</c:v>
+                  <c:v>44.7617</c:v>
                 </c:pt>
                 <c:pt idx="13">
-                  <c:v>44.93</c:v>
+                  <c:v>44.9282</c:v>
                 </c:pt>
                 <c:pt idx="14">
-                  <c:v>45.17</c:v>
+                  <c:v>45.167</c:v>
                 </c:pt>
               </c:numCache>
             </c:numRef>
@@ -1978,16 +1978,16 @@
                 <c:formatCode>General</c:formatCode>
                 <c:ptCount val="4"/>
                 <c:pt idx="0">
-                  <c:v>26.16</c:v>
+                  <c:v>26.1588</c:v>
                 </c:pt>
                 <c:pt idx="1">
-                  <c:v>29.2</c:v>
+                  <c:v>29.1997</c:v>
                 </c:pt>
                 <c:pt idx="2">
-                  <c:v>24.75</c:v>
+                  <c:v>24.7509</c:v>
                 </c:pt>
                 <c:pt idx="3">
-                  <c:v>21.68</c:v>
+                  <c:v>21.6839</c:v>
                 </c:pt>
               </c:numCache>
             </c:numRef>
@@ -2067,16 +2067,16 @@
                 <c:formatCode>General</c:formatCode>
                 <c:ptCount val="4"/>
                 <c:pt idx="0">
-                  <c:v>53.08</c:v>
+                  <c:v>53.0824</c:v>
                 </c:pt>
                 <c:pt idx="1">
-                  <c:v>52.23</c:v>
+                  <c:v>52.2272</c:v>
                 </c:pt>
                 <c:pt idx="2">
-                  <c:v>51.73</c:v>
+                  <c:v>51.7309</c:v>
                 </c:pt>
                 <c:pt idx="3">
-                  <c:v>49.56</c:v>
+                  <c:v>49.5576</c:v>
                 </c:pt>
               </c:numCache>
             </c:numRef>
@@ -2333,19 +2333,19 @@
                 <c:formatCode>General</c:formatCode>
                 <c:ptCount val="5"/>
                 <c:pt idx="0">
-                  <c:v>46.62</c:v>
+                  <c:v>46.6186</c:v>
                 </c:pt>
                 <c:pt idx="1">
-                  <c:v>55.79</c:v>
+                  <c:v>55.7877</c:v>
                 </c:pt>
                 <c:pt idx="2">
-                  <c:v>53.64</c:v>
+                  <c:v>53.6427</c:v>
                 </c:pt>
                 <c:pt idx="3">
-                  <c:v>51.74</c:v>
+                  <c:v>51.743</c:v>
                 </c:pt>
                 <c:pt idx="4">
-                  <c:v>44.18</c:v>
+                  <c:v>44.1767</c:v>
                 </c:pt>
               </c:numCache>
             </c:numRef>
@@ -2428,19 +2428,19 @@
                 <c:formatCode>General</c:formatCode>
                 <c:ptCount val="5"/>
                 <c:pt idx="0">
-                  <c:v>36.1</c:v>
+                  <c:v>36.1008</c:v>
                 </c:pt>
                 <c:pt idx="1">
-                  <c:v>34.51</c:v>
+                  <c:v>34.5055</c:v>
                 </c:pt>
                 <c:pt idx="2">
-                  <c:v>38.16</c:v>
+                  <c:v>38.1568</c:v>
                 </c:pt>
                 <c:pt idx="3">
-                  <c:v>36.07</c:v>
+                  <c:v>36.0709</c:v>
                 </c:pt>
                 <c:pt idx="4">
-                  <c:v>33.36</c:v>
+                  <c:v>33.3587</c:v>
                 </c:pt>
               </c:numCache>
             </c:numRef>
@@ -2697,19 +2697,19 @@
                 <c:formatCode>General</c:formatCode>
                 <c:ptCount val="5"/>
                 <c:pt idx="0">
-                  <c:v>38.14</c:v>
+                  <c:v>38.1442</c:v>
                 </c:pt>
                 <c:pt idx="1">
-                  <c:v>40.31</c:v>
+                  <c:v>40.3108</c:v>
                 </c:pt>
                 <c:pt idx="2">
-                  <c:v>45.08</c:v>
+                  <c:v>45.0789</c:v>
                 </c:pt>
                 <c:pt idx="3">
-                  <c:v>40.01</c:v>
+                  <c:v>40.0076</c:v>
                 </c:pt>
                 <c:pt idx="4">
-                  <c:v>35.79</c:v>
+                  <c:v>35.7895</c:v>
                 </c:pt>
               </c:numCache>
             </c:numRef>
@@ -2792,19 +2792,19 @@
                 <c:formatCode>General</c:formatCode>
                 <c:ptCount val="5"/>
                 <c:pt idx="0">
-                  <c:v>41.11</c:v>
+                  <c:v>41.113</c:v>
                 </c:pt>
                 <c:pt idx="1">
-                  <c:v>42.42</c:v>
+                  <c:v>42.4157</c:v>
                 </c:pt>
                 <c:pt idx="2">
-                  <c:v>47.43</c:v>
+                  <c:v>47.4301</c:v>
                 </c:pt>
                 <c:pt idx="3">
-                  <c:v>38.97</c:v>
+                  <c:v>38.9719</c:v>
                 </c:pt>
                 <c:pt idx="4">
-                  <c:v>33.41</c:v>
+                  <c:v>33.413</c:v>
                 </c:pt>
               </c:numCache>
             </c:numRef>
@@ -21848,7 +21848,7 @@
                           <a:ea typeface="Calibri" pitchFamily="34" charset="-122"/>
                           <a:cs typeface="Calibri" pitchFamily="34" charset="-120"/>
                         </a:rPr>
-                        <a:t>64.3%</a:t>
+                        <a:t>64.2%</a:t>
                       </a:r>
                       <a:endParaRPr lang="en-US" sz="1150" dirty="0">
                         <a:latin typeface="Calibri" charset="0"/>
@@ -40805,7 +40805,7 @@
                 <a:ea typeface="Calibri" pitchFamily="34" charset="-122"/>
                 <a:cs typeface="Calibri" pitchFamily="34" charset="-120"/>
               </a:rPr>
-              <a:t>The pattern holds in every constituency, from 70.1% to 76.6% of those aged 80 and over and 19.3% to 25.6% of those aged 18 to 24.</a:t>
+              <a:t>The pattern holds in every constituency, from 70.1% to 76.6% of those aged 80 and over and 19.3% to 25.7% of those aged 18 to 24.</a:t>
             </a:r>
             <a:endParaRPr lang="en-US" sz="1400" dirty="0"/>
           </a:p>

</xml_diff>

<commit_message>
Daily SIR check, 30 October: schedule moved in six states, Form 7 and Kerala hearings, ERONET reports, notices, events, reading
Co-Authored-By: Claude Opus 5.5 <noreply@anthropic.com>
Claude-Session: https://claude.ai/code/session_012JjD5mhtvLxzAXoZHMZYE5
</commit_message>
<xml_diff>
--- a/reports/hyderabad-old-city-sir-2026-deck.pptx
+++ b/reports/hyderabad-old-city-sir-2026-deck.pptx
@@ -4747,7 +4747,7 @@
           <a:p>
             <a:r>
               <a:rPr lang="en-US" dirty="0"/>
-              <a:t>The Special Intensive Revision (SIR) is the Election Commission's house-to-house recheck of the electoral roll. The lists cover every elector on the rolls of the five constituencies before the revision, so each group has a true exclusion rate, the share of its own members left off. These are the September 2026 lists. The final roll is due on 9 November, so names put back after hearings are not in them.</a:t>
+              <a:t>The Special Intensive Revision (SIR) is the Election Commission's house-to-house recheck of the electoral roll. The lists cover every elector on the rolls of the five constituencies before the revision, so each group has a true exclusion rate, the share of its own members left off. These are the September 2026 lists. The final roll is due on 30 November, so names put back after hearings are not in them.</a:t>
             </a:r>
             <a:endParaRPr lang="en-US" dirty="0"/>
           </a:p>
@@ -5275,7 +5275,7 @@
           <a:p>
             <a:r>
               <a:rPr lang="en-US" dirty="0"/>
-              <a:t>On 7 September the Commission extended the calendar, with claims to 7 October, hearings to 5 November and the final roll on 9 November. The schedules here are those in the September lists. The length of a slot is not recorded.</a:t>
+              <a:t>On 7 September the Commission extended the calendar, with claims to 7 October, and on 29 October it moved hearings to 26 November and the final roll to 30 November. The schedules here are those in the September lists. The length of a slot is not recorded.</a:t>
             </a:r>
             <a:endParaRPr lang="en-US" dirty="0"/>
           </a:p>
@@ -27884,7 +27884,7 @@
                 <a:ea typeface="Calibri" pitchFamily="34" charset="-122"/>
                 <a:cs typeface="Calibri" pitchFamily="34" charset="-120"/>
               </a:rPr>
-              <a:t>These are the September lists. The final roll is due on 9 November, so restorations after hearings are not in these counts. Malakpet's list is read by polling-station name (60 stations) and 7,891 electors on its roll appear in none of the three outcomes.</a:t>
+              <a:t>These are the September lists. The final roll is due on 30 November, so restorations after hearings are not in these counts. Malakpet's list is read by polling-station name (60 stations) and 7,891 electors on its roll appear in none of the three outcomes.</a:t>
             </a:r>
             <a:endParaRPr lang="en-US" sz="1600" dirty="0"/>
           </a:p>

</xml_diff>